<commit_message>
pitch: Version B deck (editorial variant) + slide transitions in both decks
- deck_engine: p14 slide transitions (fade / push / fade-through-black, ms durations, optional auto-advance),
  picture rotation + cropping, translucent text runs, deck-level backdrop and slide numeral, gradient angle fix
  (OOXML 90° = top→bottom)
- build_deck_b.py: same 13-slide arc and narration, re-composed — dot-grid backdrop, ExtraBold accent headlines,
  ink cards, stacked phones, phone-over-browser demo, rules with their code, on-device architecture diagram,
  date-proportional six-week timeline, comparison table, HR card over the code
- make_assets: bg-mesh backdrop; prune scans every build_deck*.py
- Version A: push into the demo, fade-through-black into the close; README + VIDEO_SCRIPT cover both versions

Co-authored-by: arena-agent <297053741+arena-agent@users.noreply.github.com>
</commit_message>
<xml_diff>
--- a/pitch/CareSphere_Congressional_App_Challenge_Deck.pptx
+++ b/pitch/CareSphere_Congressional_App_Challenge_Deck.pptx
@@ -4383,7 +4383,7 @@
               <a:srgbClr val="0F2659"/>
             </a:gs>
           </a:gsLst>
-          <a:lin scaled="0" ang="16200000"/>
+          <a:lin scaled="0" ang="5400000"/>
         </a:gradFill>
         <a:effectLst/>
       </p:bgPr>
@@ -4768,6 +4768,18 @@
   <p:clrMapOvr>
     <a:masterClrMapping/>
   </p:clrMapOvr>
+  <mc:AlternateContent xmlns:mc="http://schemas.openxmlformats.org/markup-compatibility/2006">
+    <mc:Choice xmlns:p14="http://schemas.microsoft.com/office/powerpoint/2010/main" Requires="p14">
+      <p:transition spd="med" p14:dur="600">
+        <p:fade/>
+      </p:transition>
+    </mc:Choice>
+    <mc:Fallback>
+      <p:transition spd="med">
+        <p:fade/>
+      </p:transition>
+    </mc:Fallback>
+  </mc:AlternateContent>
 </p:sld>
 </file>
 
@@ -4785,7 +4797,7 @@
               <a:srgbClr val="0F2659"/>
             </a:gs>
           </a:gsLst>
-          <a:lin scaled="0" ang="16200000"/>
+          <a:lin scaled="0" ang="5400000"/>
         </a:gradFill>
         <a:effectLst/>
       </p:bgPr>
@@ -6008,6 +6020,18 @@
   <p:clrMapOvr>
     <a:masterClrMapping/>
   </p:clrMapOvr>
+  <mc:AlternateContent xmlns:mc="http://schemas.openxmlformats.org/markup-compatibility/2006">
+    <mc:Choice xmlns:p14="http://schemas.microsoft.com/office/powerpoint/2010/main" Requires="p14">
+      <p:transition spd="med" p14:dur="600">
+        <p:fade/>
+      </p:transition>
+    </mc:Choice>
+    <mc:Fallback>
+      <p:transition spd="med">
+        <p:fade/>
+      </p:transition>
+    </mc:Fallback>
+  </mc:AlternateContent>
 </p:sld>
 </file>
 
@@ -6025,7 +6049,7 @@
               <a:srgbClr val="0F2659"/>
             </a:gs>
           </a:gsLst>
-          <a:lin scaled="0" ang="16200000"/>
+          <a:lin scaled="0" ang="5400000"/>
         </a:gradFill>
         <a:effectLst/>
       </p:bgPr>
@@ -7156,6 +7180,18 @@
   <p:clrMapOvr>
     <a:masterClrMapping/>
   </p:clrMapOvr>
+  <mc:AlternateContent xmlns:mc="http://schemas.openxmlformats.org/markup-compatibility/2006">
+    <mc:Choice xmlns:p14="http://schemas.microsoft.com/office/powerpoint/2010/main" Requires="p14">
+      <p:transition spd="med" p14:dur="600">
+        <p:fade/>
+      </p:transition>
+    </mc:Choice>
+    <mc:Fallback>
+      <p:transition spd="med">
+        <p:fade/>
+      </p:transition>
+    </mc:Fallback>
+  </mc:AlternateContent>
 </p:sld>
 </file>
 
@@ -7173,7 +7209,7 @@
               <a:srgbClr val="0F2659"/>
             </a:gs>
           </a:gsLst>
-          <a:lin scaled="0" ang="16200000"/>
+          <a:lin scaled="0" ang="5400000"/>
         </a:gradFill>
         <a:effectLst/>
       </p:bgPr>
@@ -8491,6 +8527,18 @@
   <p:clrMapOvr>
     <a:masterClrMapping/>
   </p:clrMapOvr>
+  <mc:AlternateContent xmlns:mc="http://schemas.openxmlformats.org/markup-compatibility/2006">
+    <mc:Choice xmlns:p14="http://schemas.microsoft.com/office/powerpoint/2010/main" Requires="p14">
+      <p:transition spd="med" p14:dur="600">
+        <p:fade/>
+      </p:transition>
+    </mc:Choice>
+    <mc:Fallback>
+      <p:transition spd="med">
+        <p:fade/>
+      </p:transition>
+    </mc:Fallback>
+  </mc:AlternateContent>
 </p:sld>
 </file>
 
@@ -8508,7 +8556,7 @@
               <a:srgbClr val="0F2659"/>
             </a:gs>
           </a:gsLst>
-          <a:lin scaled="0" ang="16200000"/>
+          <a:lin scaled="0" ang="5400000"/>
         </a:gradFill>
         <a:effectLst/>
       </p:bgPr>
@@ -8973,6 +9021,18 @@
   <p:clrMapOvr>
     <a:masterClrMapping/>
   </p:clrMapOvr>
+  <mc:AlternateContent xmlns:mc="http://schemas.openxmlformats.org/markup-compatibility/2006">
+    <mc:Choice xmlns:p14="http://schemas.microsoft.com/office/powerpoint/2010/main" Requires="p14">
+      <p:transition spd="slow" p14:dur="900">
+        <p:fade thruBlk="1"/>
+      </p:transition>
+    </mc:Choice>
+    <mc:Fallback>
+      <p:transition spd="slow">
+        <p:fade thruBlk="1"/>
+      </p:transition>
+    </mc:Fallback>
+  </mc:AlternateContent>
 </p:sld>
 </file>
 
@@ -8990,7 +9050,7 @@
               <a:srgbClr val="0F2659"/>
             </a:gs>
           </a:gsLst>
-          <a:lin scaled="0" ang="16200000"/>
+          <a:lin scaled="0" ang="5400000"/>
         </a:gradFill>
         <a:effectLst/>
       </p:bgPr>
@@ -9377,6 +9437,18 @@
   <p:clrMapOvr>
     <a:masterClrMapping/>
   </p:clrMapOvr>
+  <mc:AlternateContent xmlns:mc="http://schemas.openxmlformats.org/markup-compatibility/2006">
+    <mc:Choice xmlns:p14="http://schemas.microsoft.com/office/powerpoint/2010/main" Requires="p14">
+      <p:transition spd="med" p14:dur="600">
+        <p:fade/>
+      </p:transition>
+    </mc:Choice>
+    <mc:Fallback>
+      <p:transition spd="med">
+        <p:fade/>
+      </p:transition>
+    </mc:Fallback>
+  </mc:AlternateContent>
 </p:sld>
 </file>
 
@@ -9394,7 +9466,7 @@
               <a:srgbClr val="0F2659"/>
             </a:gs>
           </a:gsLst>
-          <a:lin scaled="0" ang="16200000"/>
+          <a:lin scaled="0" ang="5400000"/>
         </a:gradFill>
         <a:effectLst/>
       </p:bgPr>
@@ -10134,6 +10206,18 @@
   <p:clrMapOvr>
     <a:masterClrMapping/>
   </p:clrMapOvr>
+  <mc:AlternateContent xmlns:mc="http://schemas.openxmlformats.org/markup-compatibility/2006">
+    <mc:Choice xmlns:p14="http://schemas.microsoft.com/office/powerpoint/2010/main" Requires="p14">
+      <p:transition spd="med" p14:dur="600">
+        <p:fade/>
+      </p:transition>
+    </mc:Choice>
+    <mc:Fallback>
+      <p:transition spd="med">
+        <p:fade/>
+      </p:transition>
+    </mc:Fallback>
+  </mc:AlternateContent>
 </p:sld>
 </file>
 
@@ -10151,7 +10235,7 @@
               <a:srgbClr val="0F2659"/>
             </a:gs>
           </a:gsLst>
-          <a:lin scaled="0" ang="16200000"/>
+          <a:lin scaled="0" ang="5400000"/>
         </a:gradFill>
         <a:effectLst/>
       </p:bgPr>
@@ -11348,6 +11432,18 @@
   <p:clrMapOvr>
     <a:masterClrMapping/>
   </p:clrMapOvr>
+  <mc:AlternateContent xmlns:mc="http://schemas.openxmlformats.org/markup-compatibility/2006">
+    <mc:Choice xmlns:p14="http://schemas.microsoft.com/office/powerpoint/2010/main" Requires="p14">
+      <p:transition spd="med" p14:dur="600">
+        <p:fade/>
+      </p:transition>
+    </mc:Choice>
+    <mc:Fallback>
+      <p:transition spd="med">
+        <p:fade/>
+      </p:transition>
+    </mc:Fallback>
+  </mc:AlternateContent>
 </p:sld>
 </file>
 
@@ -11365,7 +11461,7 @@
               <a:srgbClr val="0F2659"/>
             </a:gs>
           </a:gsLst>
-          <a:lin scaled="0" ang="16200000"/>
+          <a:lin scaled="0" ang="5400000"/>
         </a:gradFill>
         <a:effectLst/>
       </p:bgPr>
@@ -11986,6 +12082,18 @@
   <p:clrMapOvr>
     <a:masterClrMapping/>
   </p:clrMapOvr>
+  <mc:AlternateContent xmlns:mc="http://schemas.openxmlformats.org/markup-compatibility/2006">
+    <mc:Choice xmlns:p14="http://schemas.microsoft.com/office/powerpoint/2010/main" Requires="p14">
+      <p:transition spd="med" p14:dur="600">
+        <p:fade/>
+      </p:transition>
+    </mc:Choice>
+    <mc:Fallback>
+      <p:transition spd="med">
+        <p:fade/>
+      </p:transition>
+    </mc:Fallback>
+  </mc:AlternateContent>
 </p:sld>
 </file>
 
@@ -12003,7 +12111,7 @@
               <a:srgbClr val="0F2659"/>
             </a:gs>
           </a:gsLst>
-          <a:lin scaled="0" ang="16200000"/>
+          <a:lin scaled="0" ang="5400000"/>
         </a:gradFill>
         <a:effectLst/>
       </p:bgPr>
@@ -12798,6 +12906,18 @@
   <p:clrMapOvr>
     <a:masterClrMapping/>
   </p:clrMapOvr>
+  <mc:AlternateContent xmlns:mc="http://schemas.openxmlformats.org/markup-compatibility/2006">
+    <mc:Choice xmlns:p14="http://schemas.microsoft.com/office/powerpoint/2010/main" Requires="p14">
+      <p:transition spd="med" p14:dur="650">
+        <p:push dir="l"/>
+      </p:transition>
+    </mc:Choice>
+    <mc:Fallback>
+      <p:transition spd="med">
+        <p:push dir="l"/>
+      </p:transition>
+    </mc:Fallback>
+  </mc:AlternateContent>
 </p:sld>
 </file>
 
@@ -12815,7 +12935,7 @@
               <a:srgbClr val="0F2659"/>
             </a:gs>
           </a:gsLst>
-          <a:lin scaled="0" ang="16200000"/>
+          <a:lin scaled="0" ang="5400000"/>
         </a:gradFill>
         <a:effectLst/>
       </p:bgPr>
@@ -13838,6 +13958,18 @@
   <p:clrMapOvr>
     <a:masterClrMapping/>
   </p:clrMapOvr>
+  <mc:AlternateContent xmlns:mc="http://schemas.openxmlformats.org/markup-compatibility/2006">
+    <mc:Choice xmlns:p14="http://schemas.microsoft.com/office/powerpoint/2010/main" Requires="p14">
+      <p:transition spd="med" p14:dur="600">
+        <p:fade/>
+      </p:transition>
+    </mc:Choice>
+    <mc:Fallback>
+      <p:transition spd="med">
+        <p:fade/>
+      </p:transition>
+    </mc:Fallback>
+  </mc:AlternateContent>
 </p:sld>
 </file>
 
@@ -13855,7 +13987,7 @@
               <a:srgbClr val="0F2659"/>
             </a:gs>
           </a:gsLst>
-          <a:lin scaled="0" ang="16200000"/>
+          <a:lin scaled="0" ang="5400000"/>
         </a:gradFill>
         <a:effectLst/>
       </p:bgPr>
@@ -14630,6 +14762,18 @@
   <p:clrMapOvr>
     <a:masterClrMapping/>
   </p:clrMapOvr>
+  <mc:AlternateContent xmlns:mc="http://schemas.openxmlformats.org/markup-compatibility/2006">
+    <mc:Choice xmlns:p14="http://schemas.microsoft.com/office/powerpoint/2010/main" Requires="p14">
+      <p:transition spd="med" p14:dur="600">
+        <p:fade/>
+      </p:transition>
+    </mc:Choice>
+    <mc:Fallback>
+      <p:transition spd="med">
+        <p:fade/>
+      </p:transition>
+    </mc:Fallback>
+  </mc:AlternateContent>
 </p:sld>
 </file>
 
@@ -14647,7 +14791,7 @@
               <a:srgbClr val="0F2659"/>
             </a:gs>
           </a:gsLst>
-          <a:lin scaled="0" ang="16200000"/>
+          <a:lin scaled="0" ang="5400000"/>
         </a:gradFill>
         <a:effectLst/>
       </p:bgPr>
@@ -15399,6 +15543,18 @@
   <p:clrMapOvr>
     <a:masterClrMapping/>
   </p:clrMapOvr>
+  <mc:AlternateContent xmlns:mc="http://schemas.openxmlformats.org/markup-compatibility/2006">
+    <mc:Choice xmlns:p14="http://schemas.microsoft.com/office/powerpoint/2010/main" Requires="p14">
+      <p:transition spd="med" p14:dur="600">
+        <p:fade/>
+      </p:transition>
+    </mc:Choice>
+    <mc:Fallback>
+      <p:transition spd="med">
+        <p:fade/>
+      </p:transition>
+    </mc:Fallback>
+  </mc:AlternateContent>
 </p:sld>
 </file>
 

</xml_diff>

<commit_message>
pitch: CAC portal application kit — six 400-word answers, cover photo, field-by-field guide
- APPLICATION_ANSWERS.md: every portal field with what to enter; full drafts of the six long answers
  (380/337/382/342/332/379 words), each grounded in the repository with fact notes and [brackets] for
  what only the student can say; process questions; pre-submit checklist; LICENSE note for Hack Club certification
- make_cover.py → cover/CareSphere_cover_600x800.jpg (+1200x1600): 3:4 JPEG from the real icon + screenshot
- Decks: name (Arnav Kochar), district (CA-10) and email filled in; slide-12 'Then' items now only roadmap-backed
- VIDEO_SCRIPT / README updated to point at the new answers; obsolete character-limit drafts removed

Co-authored-by: arena-agent <297053741+arena-agent@users.noreply.github.com>
</commit_message>
<xml_diff>
--- a/pitch/CareSphere_Congressional_App_Challenge_Deck.pptx
+++ b/pitch/CareSphere_Congressional_App_Challenge_Deck.pptx
@@ -533,7 +533,7 @@
           <a:lstStyle/>
           <a:p>
             <a:r>
-              <a:t>[0:00–0:14] Hi, I'm [NAME], a [GRADE] at [SCHOOL] in [CITY], California. This is CareSphere AI — a private care companion for older adults, autistic people and their families, on iPhone and on the web.</a:t>
+              <a:t>[0:00–0:14] Hi, I'm Arnav Kochar, a [GRADE] at [SCHOOL] in [CITY], California. This is CareSphere AI — a private care companion for older adults, autistic people and their families, on iPhone and on the web.</a:t>
             </a:r>
           </a:p>
         </p:txBody>
@@ -4504,7 +4504,7 @@
                 </a:solidFill>
                 <a:latin typeface="Plus Jakarta Sans"/>
               </a:rPr>
-              <a:t>CONGRESSIONAL APP CHALLENGE 2026  ·  [CA-XX]</a:t>
+              <a:t>CONGRESSIONAL APP CHALLENGE 2026  ·  CA-10</a:t>
             </a:r>
           </a:p>
         </p:txBody>
@@ -4688,7 +4688,7 @@
                 </a:solidFill>
                 <a:latin typeface="Plus Jakarta Sans"/>
               </a:rPr>
-              <a:t>[Student Name]</a:t>
+              <a:t>Arnav Kochar</a:t>
             </a:r>
           </a:p>
         </p:txBody>
@@ -4734,7 +4734,7 @@
                 </a:solidFill>
                 <a:latin typeface="Plus Jakarta Sans"/>
               </a:rPr>
-              <a:t>[School]  ·  [City], California  ·  [email@example.com]</a:t>
+              <a:t>[School]  ·  [City], California  ·  kochar4646@gmail.com</a:t>
             </a:r>
           </a:p>
         </p:txBody>
@@ -7935,7 +7935,7 @@
                 </a:solidFill>
                 <a:latin typeface="Plus Jakarta Sans"/>
               </a:rPr>
-              <a:t>sensor history in the visit brief · encrypted backup · Spanish</a:t>
+              <a:t>sensor history in the visit brief · trends only from real readings</a:t>
             </a:r>
           </a:p>
         </p:txBody>
@@ -8843,7 +8843,7 @@
                 </a:solidFill>
                 <a:latin typeface="Plus Jakarta Sans"/>
               </a:rPr>
-              <a:t>[Student Name]  ·  [email@example.com]  ·  [School], [City], California</a:t>
+              <a:t>Arnav Kochar  ·  kochar4646@gmail.com  ·  [School], [City], California</a:t>
             </a:r>
           </a:p>
         </p:txBody>
@@ -9239,7 +9239,7 @@
                 </a:solidFill>
                 <a:latin typeface="Plus Jakarta Sans Medium"/>
               </a:rPr>
-              <a:t>— [Student Name], [grade], [School]</a:t>
+              <a:t>— Arnav Kochar, [grade], [School]</a:t>
             </a:r>
           </a:p>
         </p:txBody>

</xml_diff>